<commit_message>
style(poster): remove pitch plausibility caption
</commit_message>
<xml_diff>
--- a/poster/pitch/deliverables/cel-poster-pitch.pptx
+++ b/poster/pitch/deliverables/cel-poster-pitch.pptx
@@ -2139,7 +2139,7 @@
         <p:spPr>
           <a:xfrm>
             <a:off x="7900368" y="1447800"/>
-            <a:ext cx="3834283" cy="349151"/>
+            <a:ext cx="3834283" cy="174575"/>
           </a:xfrm>
           <a:prstGeom prst="rect">
             <a:avLst/>
@@ -2167,26 +2167,6 @@
                 <a:cs typeface="Arial" pitchFamily="34" charset="-120"/>
               </a:rPr>
               <a:t>Adult Census · LR + MLP</a:t>
-            </a:r>
-            <a:endParaRPr lang="en-US" sz="1100" dirty="0"/>
-          </a:p>
-          <a:p>
-            <a:pPr algn="r" indent="0" marL="0">
-              <a:lnSpc>
-                <a:spcPts val="1375"/>
-              </a:lnSpc>
-              <a:buNone/>
-            </a:pPr>
-            <a:r>
-              <a:rPr lang="en-US" sz="1100" dirty="0">
-                <a:solidFill>
-                  <a:srgbClr val="536274"/>
-                </a:solidFill>
-                <a:latin typeface="Arial" pitchFamily="34" charset="0"/>
-                <a:ea typeface="Arial" pitchFamily="34" charset="-122"/>
-                <a:cs typeface="Arial" pitchFamily="34" charset="-120"/>
-              </a:rPr>
-              <a:t>Plausibility: log-density (↑)</a:t>
             </a:r>
             <a:endParaRPr lang="en-US" sz="1100" dirty="0"/>
           </a:p>

</xml_diff>